<commit_message>
docs: add thesis slides
</commit_message>
<xml_diff>
--- a/docs/presentation/Presentazione_Tesi_finale.pptx
+++ b/docs/presentation/Presentazione_Tesi_finale.pptx
@@ -115,7 +115,7 @@
   </p:defaultTextStyle>
   <p:extLst>
     <p:ext uri="{EFAFB233-063F-42B5-8137-9DF3F51BA10A}">
-      <p15:sldGuideLst xmlns:p15="http://schemas.microsoft.com/office/powerpoint/2012/main" xmlns=""/>
+      <p15:sldGuideLst xmlns="" xmlns:p15="http://schemas.microsoft.com/office/powerpoint/2012/main"/>
     </p:ext>
   </p:extLst>
 </p:presentation>
@@ -3056,7 +3056,7 @@
           <p:cNvPr id="7" name="CasellaDiTesto 6">
             <a:extLst>
               <a:ext uri="{FF2B5EF4-FFF2-40B4-BE49-F238E27FC236}">
-                <a16:creationId xmlns:a16="http://schemas.microsoft.com/office/drawing/2014/main" xmlns="" id="{85474058-BD37-D9CB-3E3F-9F9A0039EA9A}"/>
+                <a16:creationId xmlns="" xmlns:a16="http://schemas.microsoft.com/office/drawing/2014/main" id="{85474058-BD37-D9CB-3E3F-9F9A0039EA9A}"/>
               </a:ext>
             </a:extLst>
           </p:cNvPr>
@@ -3111,7 +3111,7 @@
           <p:cNvPr id="9" name="CasellaDiTesto 8">
             <a:extLst>
               <a:ext uri="{FF2B5EF4-FFF2-40B4-BE49-F238E27FC236}">
-                <a16:creationId xmlns:a16="http://schemas.microsoft.com/office/drawing/2014/main" xmlns="" id="{5A21BA64-3BB0-9C77-2853-9C7455BAB1AA}"/>
+                <a16:creationId xmlns="" xmlns:a16="http://schemas.microsoft.com/office/drawing/2014/main" id="{5A21BA64-3BB0-9C77-2853-9C7455BAB1AA}"/>
               </a:ext>
             </a:extLst>
           </p:cNvPr>
@@ -3147,7 +3147,7 @@
           <p:cNvPr id="11" name="CasellaDiTesto 10">
             <a:extLst>
               <a:ext uri="{FF2B5EF4-FFF2-40B4-BE49-F238E27FC236}">
-                <a16:creationId xmlns:a16="http://schemas.microsoft.com/office/drawing/2014/main" xmlns="" id="{5BBF22FB-5410-D9FC-1A9C-7A3B6B18E793}"/>
+                <a16:creationId xmlns="" xmlns:a16="http://schemas.microsoft.com/office/drawing/2014/main" id="{5BBF22FB-5410-D9FC-1A9C-7A3B6B18E793}"/>
               </a:ext>
             </a:extLst>
           </p:cNvPr>
@@ -3202,7 +3202,7 @@
           <p:cNvPr id="13" name="CasellaDiTesto 12">
             <a:extLst>
               <a:ext uri="{FF2B5EF4-FFF2-40B4-BE49-F238E27FC236}">
-                <a16:creationId xmlns:a16="http://schemas.microsoft.com/office/drawing/2014/main" xmlns="" id="{E92E452E-7326-50AB-01E9-83E72CD1CFF5}"/>
+                <a16:creationId xmlns="" xmlns:a16="http://schemas.microsoft.com/office/drawing/2014/main" id="{E92E452E-7326-50AB-01E9-83E72CD1CFF5}"/>
               </a:ext>
             </a:extLst>
           </p:cNvPr>
@@ -3246,7 +3246,7 @@
           <p:cNvPr id="15" name="CasellaDiTesto 14">
             <a:extLst>
               <a:ext uri="{FF2B5EF4-FFF2-40B4-BE49-F238E27FC236}">
-                <a16:creationId xmlns:a16="http://schemas.microsoft.com/office/drawing/2014/main" xmlns="" id="{631C4C7A-522F-7C54-1FC1-D8E9FC63DEA3}"/>
+                <a16:creationId xmlns="" xmlns:a16="http://schemas.microsoft.com/office/drawing/2014/main" id="{631C4C7A-522F-7C54-1FC1-D8E9FC63DEA3}"/>
               </a:ext>
             </a:extLst>
           </p:cNvPr>
@@ -3302,7 +3302,7 @@
           <p:cNvPr id="17" name="CasellaDiTesto 16">
             <a:extLst>
               <a:ext uri="{FF2B5EF4-FFF2-40B4-BE49-F238E27FC236}">
-                <a16:creationId xmlns:a16="http://schemas.microsoft.com/office/drawing/2014/main" xmlns="" id="{4FEFD790-1215-3137-AB39-0388EDF869AC}"/>
+                <a16:creationId xmlns="" xmlns:a16="http://schemas.microsoft.com/office/drawing/2014/main" id="{4FEFD790-1215-3137-AB39-0388EDF869AC}"/>
               </a:ext>
             </a:extLst>
           </p:cNvPr>
@@ -3351,7 +3351,7 @@
           <p:cNvPr id="18" name="CasellaDiTesto 17">
             <a:extLst>
               <a:ext uri="{FF2B5EF4-FFF2-40B4-BE49-F238E27FC236}">
-                <a16:creationId xmlns:a16="http://schemas.microsoft.com/office/drawing/2014/main" xmlns="" id="{75D61FD1-CA7E-8171-78BB-CC43B113D2E2}"/>
+                <a16:creationId xmlns="" xmlns:a16="http://schemas.microsoft.com/office/drawing/2014/main" id="{75D61FD1-CA7E-8171-78BB-CC43B113D2E2}"/>
               </a:ext>
             </a:extLst>
           </p:cNvPr>
@@ -3396,7 +3396,7 @@
           <p:cNvPr id="20" name="Connettore diritto 19">
             <a:extLst>
               <a:ext uri="{FF2B5EF4-FFF2-40B4-BE49-F238E27FC236}">
-                <a16:creationId xmlns:a16="http://schemas.microsoft.com/office/drawing/2014/main" xmlns="" id="{4B936019-E24E-D7B6-21F6-A1ABFCF8A73D}"/>
+                <a16:creationId xmlns="" xmlns:a16="http://schemas.microsoft.com/office/drawing/2014/main" id="{4B936019-E24E-D7B6-21F6-A1ABFCF8A73D}"/>
               </a:ext>
             </a:extLst>
           </p:cNvPr>
@@ -3437,7 +3437,7 @@
           <p:cNvPr id="21" name="Immagine 20">
             <a:extLst>
               <a:ext uri="{FF2B5EF4-FFF2-40B4-BE49-F238E27FC236}">
-                <a16:creationId xmlns:a16="http://schemas.microsoft.com/office/drawing/2014/main" xmlns="" id="{00A020C2-C842-F81E-7142-3955B75FFBC0}"/>
+                <a16:creationId xmlns="" xmlns:a16="http://schemas.microsoft.com/office/drawing/2014/main" id="{00A020C2-C842-F81E-7142-3955B75FFBC0}"/>
               </a:ext>
             </a:extLst>
           </p:cNvPr>
@@ -3467,7 +3467,7 @@
           <p:cNvPr id="22" name="Connettore diritto 21">
             <a:extLst>
               <a:ext uri="{FF2B5EF4-FFF2-40B4-BE49-F238E27FC236}">
-                <a16:creationId xmlns:a16="http://schemas.microsoft.com/office/drawing/2014/main" xmlns="" id="{238EAD03-A050-5FFE-35F3-60DEDCADA986}"/>
+                <a16:creationId xmlns="" xmlns:a16="http://schemas.microsoft.com/office/drawing/2014/main" id="{238EAD03-A050-5FFE-35F3-60DEDCADA986}"/>
               </a:ext>
             </a:extLst>
           </p:cNvPr>
@@ -3517,7 +3517,7 @@
   </p:clrMapOvr>
   <p:extLst>
     <p:ext uri="{6950BFC3-D8DA-4A85-94F7-54DA5524770B}">
-      <p188:commentRel xmlns:p188="http://schemas.microsoft.com/office/powerpoint/2018/8/main" xmlns="" r:id="rId3"/>
+      <p188:commentRel xmlns="" xmlns:p188="http://schemas.microsoft.com/office/powerpoint/2018/8/main" r:id="rId3"/>
     </p:ext>
   </p:extLst>
 </p:sld>
@@ -3545,7 +3545,7 @@
           <p:cNvPr id="4" name="CasellaDiTesto 3">
             <a:extLst>
               <a:ext uri="{FF2B5EF4-FFF2-40B4-BE49-F238E27FC236}">
-                <a16:creationId xmlns:a16="http://schemas.microsoft.com/office/drawing/2014/main" xmlns="" id="{90F77E46-C4F6-213D-457D-2FE61E9CF9C8}"/>
+                <a16:creationId xmlns="" xmlns:a16="http://schemas.microsoft.com/office/drawing/2014/main" id="{90F77E46-C4F6-213D-457D-2FE61E9CF9C8}"/>
               </a:ext>
             </a:extLst>
           </p:cNvPr>
@@ -3586,7 +3586,7 @@
           <p:cNvPr id="6" name="CasellaDiTesto 5">
             <a:extLst>
               <a:ext uri="{FF2B5EF4-FFF2-40B4-BE49-F238E27FC236}">
-                <a16:creationId xmlns:a16="http://schemas.microsoft.com/office/drawing/2014/main" xmlns="" id="{2D9D006C-98A5-2515-4316-673CD7569919}"/>
+                <a16:creationId xmlns="" xmlns:a16="http://schemas.microsoft.com/office/drawing/2014/main" id="{2D9D006C-98A5-2515-4316-673CD7569919}"/>
               </a:ext>
             </a:extLst>
           </p:cNvPr>
@@ -3657,7 +3657,7 @@
           <p:cNvPr id="8" name="CasellaDiTesto 7">
             <a:extLst>
               <a:ext uri="{FF2B5EF4-FFF2-40B4-BE49-F238E27FC236}">
-                <a16:creationId xmlns:a16="http://schemas.microsoft.com/office/drawing/2014/main" xmlns="" id="{B71DF602-B102-641F-2677-2FB4B92D4D89}"/>
+                <a16:creationId xmlns="" xmlns:a16="http://schemas.microsoft.com/office/drawing/2014/main" id="{B71DF602-B102-641F-2677-2FB4B92D4D89}"/>
               </a:ext>
             </a:extLst>
           </p:cNvPr>
@@ -3795,7 +3795,7 @@
           <p:cNvPr id="6" name="Freccia a destra 5">
             <a:extLst>
               <a:ext uri="{FF2B5EF4-FFF2-40B4-BE49-F238E27FC236}">
-                <a16:creationId xmlns:a16="http://schemas.microsoft.com/office/drawing/2014/main" xmlns="" id="{60F508B7-5857-14D9-4941-8DAF0B6031CD}"/>
+                <a16:creationId xmlns="" xmlns:a16="http://schemas.microsoft.com/office/drawing/2014/main" id="{60F508B7-5857-14D9-4941-8DAF0B6031CD}"/>
               </a:ext>
             </a:extLst>
           </p:cNvPr>
@@ -3849,7 +3849,7 @@
           <p:cNvPr id="7" name="CasellaDiTesto 6">
             <a:extLst>
               <a:ext uri="{FF2B5EF4-FFF2-40B4-BE49-F238E27FC236}">
-                <a16:creationId xmlns:a16="http://schemas.microsoft.com/office/drawing/2014/main" xmlns="" id="{CBAE00B6-4D60-8C4E-C607-C633D07AE144}"/>
+                <a16:creationId xmlns="" xmlns:a16="http://schemas.microsoft.com/office/drawing/2014/main" id="{CBAE00B6-4D60-8C4E-C607-C633D07AE144}"/>
               </a:ext>
             </a:extLst>
           </p:cNvPr>
@@ -3892,7 +3892,7 @@
           <p:cNvPr id="8" name="CasellaDiTesto 7">
             <a:extLst>
               <a:ext uri="{FF2B5EF4-FFF2-40B4-BE49-F238E27FC236}">
-                <a16:creationId xmlns:a16="http://schemas.microsoft.com/office/drawing/2014/main" xmlns="" id="{9BA6065A-6B20-3479-5930-B4465232ADEE}"/>
+                <a16:creationId xmlns="" xmlns:a16="http://schemas.microsoft.com/office/drawing/2014/main" id="{9BA6065A-6B20-3479-5930-B4465232ADEE}"/>
               </a:ext>
             </a:extLst>
           </p:cNvPr>
@@ -3935,7 +3935,7 @@
           <p:cNvPr id="9" name="CasellaDiTesto 8">
             <a:extLst>
               <a:ext uri="{FF2B5EF4-FFF2-40B4-BE49-F238E27FC236}">
-                <a16:creationId xmlns:a16="http://schemas.microsoft.com/office/drawing/2014/main" xmlns="" id="{5F3F5985-A587-4635-6103-9FAB7E3BD17D}"/>
+                <a16:creationId xmlns="" xmlns:a16="http://schemas.microsoft.com/office/drawing/2014/main" id="{5F3F5985-A587-4635-6103-9FAB7E3BD17D}"/>
               </a:ext>
             </a:extLst>
           </p:cNvPr>
@@ -3970,7 +3970,7 @@
           <p:cNvPr id="11" name="CasellaDiTesto 10">
             <a:extLst>
               <a:ext uri="{FF2B5EF4-FFF2-40B4-BE49-F238E27FC236}">
-                <a16:creationId xmlns:a16="http://schemas.microsoft.com/office/drawing/2014/main" xmlns="" id="{0D2FF406-0E95-7AF9-0579-566A0BF76498}"/>
+                <a16:creationId xmlns="" xmlns:a16="http://schemas.microsoft.com/office/drawing/2014/main" id="{0D2FF406-0E95-7AF9-0579-566A0BF76498}"/>
               </a:ext>
             </a:extLst>
           </p:cNvPr>
@@ -4013,7 +4013,7 @@
           <p:cNvPr id="12" name="CasellaDiTesto 11">
             <a:extLst>
               <a:ext uri="{FF2B5EF4-FFF2-40B4-BE49-F238E27FC236}">
-                <a16:creationId xmlns:a16="http://schemas.microsoft.com/office/drawing/2014/main" xmlns="" id="{A2E8151C-3CA1-8D6E-5B43-E96C73F373B1}"/>
+                <a16:creationId xmlns="" xmlns:a16="http://schemas.microsoft.com/office/drawing/2014/main" id="{A2E8151C-3CA1-8D6E-5B43-E96C73F373B1}"/>
               </a:ext>
             </a:extLst>
           </p:cNvPr>
@@ -4052,7 +4052,7 @@
           <p:cNvPr id="15" name="CasellaDiTesto 14">
             <a:extLst>
               <a:ext uri="{FF2B5EF4-FFF2-40B4-BE49-F238E27FC236}">
-                <a16:creationId xmlns:a16="http://schemas.microsoft.com/office/drawing/2014/main" xmlns="" id="{1DC804A6-98A0-6E35-693C-3D1B820E6B06}"/>
+                <a16:creationId xmlns="" xmlns:a16="http://schemas.microsoft.com/office/drawing/2014/main" id="{1DC804A6-98A0-6E35-693C-3D1B820E6B06}"/>
               </a:ext>
             </a:extLst>
           </p:cNvPr>
@@ -4093,7 +4093,7 @@
           <p:cNvPr id="17" name="Connettore diritto 16">
             <a:extLst>
               <a:ext uri="{FF2B5EF4-FFF2-40B4-BE49-F238E27FC236}">
-                <a16:creationId xmlns:a16="http://schemas.microsoft.com/office/drawing/2014/main" xmlns="" id="{35AAE4D6-3237-E06B-99A9-B8978D18E44A}"/>
+                <a16:creationId xmlns="" xmlns:a16="http://schemas.microsoft.com/office/drawing/2014/main" id="{35AAE4D6-3237-E06B-99A9-B8978D18E44A}"/>
               </a:ext>
             </a:extLst>
           </p:cNvPr>
@@ -4134,7 +4134,7 @@
           <p:cNvPr id="18" name="Connettore diritto 17">
             <a:extLst>
               <a:ext uri="{FF2B5EF4-FFF2-40B4-BE49-F238E27FC236}">
-                <a16:creationId xmlns:a16="http://schemas.microsoft.com/office/drawing/2014/main" xmlns="" id="{0788675D-E48F-8280-CD12-AB4988D1E8A1}"/>
+                <a16:creationId xmlns="" xmlns:a16="http://schemas.microsoft.com/office/drawing/2014/main" id="{0788675D-E48F-8280-CD12-AB4988D1E8A1}"/>
               </a:ext>
             </a:extLst>
           </p:cNvPr>
@@ -4177,7 +4177,7 @@
           <p:cNvPr id="19" name="Connettore diritto 18">
             <a:extLst>
               <a:ext uri="{FF2B5EF4-FFF2-40B4-BE49-F238E27FC236}">
-                <a16:creationId xmlns:a16="http://schemas.microsoft.com/office/drawing/2014/main" xmlns="" id="{BBA3F9A8-40EC-FE78-B596-0704F64D3846}"/>
+                <a16:creationId xmlns="" xmlns:a16="http://schemas.microsoft.com/office/drawing/2014/main" id="{BBA3F9A8-40EC-FE78-B596-0704F64D3846}"/>
               </a:ext>
             </a:extLst>
           </p:cNvPr>
@@ -4220,7 +4220,7 @@
           <p:cNvPr id="21" name="Connettore diritto 20">
             <a:extLst>
               <a:ext uri="{FF2B5EF4-FFF2-40B4-BE49-F238E27FC236}">
-                <a16:creationId xmlns:a16="http://schemas.microsoft.com/office/drawing/2014/main" xmlns="" id="{7DB2EB3E-12A3-5082-D801-2571DE8C829E}"/>
+                <a16:creationId xmlns="" xmlns:a16="http://schemas.microsoft.com/office/drawing/2014/main" id="{7DB2EB3E-12A3-5082-D801-2571DE8C829E}"/>
               </a:ext>
             </a:extLst>
           </p:cNvPr>
@@ -4263,7 +4263,7 @@
           <p:cNvPr id="23" name="Freccia a destra 22">
             <a:extLst>
               <a:ext uri="{FF2B5EF4-FFF2-40B4-BE49-F238E27FC236}">
-                <a16:creationId xmlns:a16="http://schemas.microsoft.com/office/drawing/2014/main" xmlns="" id="{67228C10-AEDE-4202-A13D-6A7DD8773D33}"/>
+                <a16:creationId xmlns="" xmlns:a16="http://schemas.microsoft.com/office/drawing/2014/main" id="{67228C10-AEDE-4202-A13D-6A7DD8773D33}"/>
               </a:ext>
             </a:extLst>
           </p:cNvPr>
@@ -4317,7 +4317,7 @@
           <p:cNvPr id="25" name="CasellaDiTesto 24">
             <a:extLst>
               <a:ext uri="{FF2B5EF4-FFF2-40B4-BE49-F238E27FC236}">
-                <a16:creationId xmlns:a16="http://schemas.microsoft.com/office/drawing/2014/main" xmlns="" id="{C606C472-C4A9-1AE2-2D44-EEBCBFA82468}"/>
+                <a16:creationId xmlns="" xmlns:a16="http://schemas.microsoft.com/office/drawing/2014/main" id="{C606C472-C4A9-1AE2-2D44-EEBCBFA82468}"/>
               </a:ext>
             </a:extLst>
           </p:cNvPr>
@@ -4352,7 +4352,7 @@
           <p:cNvPr id="26" name="Freccia a destra 25">
             <a:extLst>
               <a:ext uri="{FF2B5EF4-FFF2-40B4-BE49-F238E27FC236}">
-                <a16:creationId xmlns:a16="http://schemas.microsoft.com/office/drawing/2014/main" xmlns="" id="{286937DA-5DD5-3A11-7AA1-E4EB85E2A433}"/>
+                <a16:creationId xmlns="" xmlns:a16="http://schemas.microsoft.com/office/drawing/2014/main" id="{286937DA-5DD5-3A11-7AA1-E4EB85E2A433}"/>
               </a:ext>
             </a:extLst>
           </p:cNvPr>
@@ -4441,7 +4441,7 @@
               <p:cNvPr id="5" name="CasellaDiTesto 4">
                 <a:extLst>
                   <a:ext uri="{FF2B5EF4-FFF2-40B4-BE49-F238E27FC236}">
-                    <a16:creationId xmlns:a16="http://schemas.microsoft.com/office/drawing/2014/main" xmlns="" id="{C74A10A5-DC65-8648-C121-CC876EA211F0}"/>
+                    <a16:creationId xmlns="" xmlns:a16="http://schemas.microsoft.com/office/drawing/2014/main" id="{C74A10A5-DC65-8648-C121-CC876EA211F0}"/>
                   </a:ext>
                 </a:extLst>
               </p:cNvPr>
@@ -4739,7 +4739,7 @@
           <p:cNvPr id="18" name="CasellaDiTesto 17">
             <a:extLst>
               <a:ext uri="{FF2B5EF4-FFF2-40B4-BE49-F238E27FC236}">
-                <a16:creationId xmlns:a16="http://schemas.microsoft.com/office/drawing/2014/main" xmlns="" id="{5889947B-BBD5-B7BA-3F33-ACE4B57D40F9}"/>
+                <a16:creationId xmlns="" xmlns:a16="http://schemas.microsoft.com/office/drawing/2014/main" id="{5889947B-BBD5-B7BA-3F33-ACE4B57D40F9}"/>
               </a:ext>
             </a:extLst>
           </p:cNvPr>
@@ -4780,7 +4780,7 @@
           <p:cNvPr id="20" name="Connettore 2 19">
             <a:extLst>
               <a:ext uri="{FF2B5EF4-FFF2-40B4-BE49-F238E27FC236}">
-                <a16:creationId xmlns:a16="http://schemas.microsoft.com/office/drawing/2014/main" xmlns="" id="{4B2533F4-36BF-ACFC-CD62-27A70E031959}"/>
+                <a16:creationId xmlns="" xmlns:a16="http://schemas.microsoft.com/office/drawing/2014/main" id="{4B2533F4-36BF-ACFC-CD62-27A70E031959}"/>
               </a:ext>
             </a:extLst>
           </p:cNvPr>
@@ -4826,7 +4826,7 @@
               <p:cNvPr id="22" name="CasellaDiTesto 21">
                 <a:extLst>
                   <a:ext uri="{FF2B5EF4-FFF2-40B4-BE49-F238E27FC236}">
-                    <a16:creationId xmlns:a16="http://schemas.microsoft.com/office/drawing/2014/main" xmlns="" id="{0ADD8C5A-C15F-D008-3A77-E9FF1866CD0E}"/>
+                    <a16:creationId xmlns="" xmlns:a16="http://schemas.microsoft.com/office/drawing/2014/main" id="{0ADD8C5A-C15F-D008-3A77-E9FF1866CD0E}"/>
                   </a:ext>
                 </a:extLst>
               </p:cNvPr>
@@ -5213,7 +5213,7 @@
               <p:cNvPr id="23" name="CasellaDiTesto 22">
                 <a:extLst>
                   <a:ext uri="{FF2B5EF4-FFF2-40B4-BE49-F238E27FC236}">
-                    <a16:creationId xmlns:a16="http://schemas.microsoft.com/office/drawing/2014/main" xmlns="" id="{4A841AE8-C215-C537-07F1-1E44AEECE606}"/>
+                    <a16:creationId xmlns="" xmlns:a16="http://schemas.microsoft.com/office/drawing/2014/main" id="{4A841AE8-C215-C537-07F1-1E44AEECE606}"/>
                   </a:ext>
                 </a:extLst>
               </p:cNvPr>
@@ -5636,7 +5636,7 @@
               <p:cNvPr id="24" name="CasellaDiTesto 23">
                 <a:extLst>
                   <a:ext uri="{FF2B5EF4-FFF2-40B4-BE49-F238E27FC236}">
-                    <a16:creationId xmlns:a16="http://schemas.microsoft.com/office/drawing/2014/main" xmlns="" id="{C159C00D-1AA6-CB16-172C-C66E6EDD4CD6}"/>
+                    <a16:creationId xmlns="" xmlns:a16="http://schemas.microsoft.com/office/drawing/2014/main" id="{C159C00D-1AA6-CB16-172C-C66E6EDD4CD6}"/>
                   </a:ext>
                 </a:extLst>
               </p:cNvPr>
@@ -6056,7 +6056,7 @@
           <p:cNvPr id="26" name="Connettore 2 25">
             <a:extLst>
               <a:ext uri="{FF2B5EF4-FFF2-40B4-BE49-F238E27FC236}">
-                <a16:creationId xmlns:a16="http://schemas.microsoft.com/office/drawing/2014/main" xmlns="" id="{E0E41663-0BAC-5450-F01E-37CA9F765260}"/>
+                <a16:creationId xmlns="" xmlns:a16="http://schemas.microsoft.com/office/drawing/2014/main" id="{E0E41663-0BAC-5450-F01E-37CA9F765260}"/>
               </a:ext>
             </a:extLst>
           </p:cNvPr>
@@ -6100,7 +6100,7 @@
           <p:cNvPr id="27" name="Connettore 2 26">
             <a:extLst>
               <a:ext uri="{FF2B5EF4-FFF2-40B4-BE49-F238E27FC236}">
-                <a16:creationId xmlns:a16="http://schemas.microsoft.com/office/drawing/2014/main" xmlns="" id="{5DE77BA5-2AAB-5385-7EF7-D6BF1E0B4B37}"/>
+                <a16:creationId xmlns="" xmlns:a16="http://schemas.microsoft.com/office/drawing/2014/main" id="{5DE77BA5-2AAB-5385-7EF7-D6BF1E0B4B37}"/>
               </a:ext>
             </a:extLst>
           </p:cNvPr>
@@ -6144,7 +6144,7 @@
           <p:cNvPr id="28" name="CasellaDiTesto 27">
             <a:extLst>
               <a:ext uri="{FF2B5EF4-FFF2-40B4-BE49-F238E27FC236}">
-                <a16:creationId xmlns:a16="http://schemas.microsoft.com/office/drawing/2014/main" xmlns="" id="{2CEA8C95-BF49-8A21-EBD4-EBB243CE23C8}"/>
+                <a16:creationId xmlns="" xmlns:a16="http://schemas.microsoft.com/office/drawing/2014/main" id="{2CEA8C95-BF49-8A21-EBD4-EBB243CE23C8}"/>
               </a:ext>
             </a:extLst>
           </p:cNvPr>
@@ -6188,7 +6188,7 @@
           <p:cNvPr id="29" name="CasellaDiTesto 28">
             <a:extLst>
               <a:ext uri="{FF2B5EF4-FFF2-40B4-BE49-F238E27FC236}">
-                <a16:creationId xmlns:a16="http://schemas.microsoft.com/office/drawing/2014/main" xmlns="" id="{935D7506-5921-B55C-933C-39C6E60B79E4}"/>
+                <a16:creationId xmlns="" xmlns:a16="http://schemas.microsoft.com/office/drawing/2014/main" id="{935D7506-5921-B55C-933C-39C6E60B79E4}"/>
               </a:ext>
             </a:extLst>
           </p:cNvPr>
@@ -6232,7 +6232,7 @@
           <p:cNvPr id="30" name="CasellaDiTesto 29">
             <a:extLst>
               <a:ext uri="{FF2B5EF4-FFF2-40B4-BE49-F238E27FC236}">
-                <a16:creationId xmlns:a16="http://schemas.microsoft.com/office/drawing/2014/main" xmlns="" id="{634BD4F9-6EC9-AAC9-2D19-A9AE591787E2}"/>
+                <a16:creationId xmlns="" xmlns:a16="http://schemas.microsoft.com/office/drawing/2014/main" id="{634BD4F9-6EC9-AAC9-2D19-A9AE591787E2}"/>
               </a:ext>
             </a:extLst>
           </p:cNvPr>
@@ -6278,7 +6278,7 @@
               <p:cNvPr id="32" name="CasellaDiTesto 31">
                 <a:extLst>
                   <a:ext uri="{FF2B5EF4-FFF2-40B4-BE49-F238E27FC236}">
-                    <a16:creationId xmlns:a16="http://schemas.microsoft.com/office/drawing/2014/main" xmlns="" id="{05A94559-D61C-8394-D466-A0109AC5914C}"/>
+                    <a16:creationId xmlns="" xmlns:a16="http://schemas.microsoft.com/office/drawing/2014/main" id="{05A94559-D61C-8394-D466-A0109AC5914C}"/>
                   </a:ext>
                 </a:extLst>
               </p:cNvPr>
@@ -6486,7 +6486,7 @@
               <p:cNvPr id="33" name="CasellaDiTesto 32">
                 <a:extLst>
                   <a:ext uri="{FF2B5EF4-FFF2-40B4-BE49-F238E27FC236}">
-                    <a16:creationId xmlns:a16="http://schemas.microsoft.com/office/drawing/2014/main" xmlns="" id="{DC71EEF3-0ABC-C33F-9206-EC069B81096B}"/>
+                    <a16:creationId xmlns="" xmlns:a16="http://schemas.microsoft.com/office/drawing/2014/main" id="{DC71EEF3-0ABC-C33F-9206-EC069B81096B}"/>
                   </a:ext>
                 </a:extLst>
               </p:cNvPr>
@@ -6658,7 +6658,7 @@
           <p:cNvPr id="36" name="Connettore 2 35">
             <a:extLst>
               <a:ext uri="{FF2B5EF4-FFF2-40B4-BE49-F238E27FC236}">
-                <a16:creationId xmlns:a16="http://schemas.microsoft.com/office/drawing/2014/main" xmlns="" id="{B8B7B27E-5BCE-3D6A-9FDB-F6BDB25AE0D1}"/>
+                <a16:creationId xmlns="" xmlns:a16="http://schemas.microsoft.com/office/drawing/2014/main" id="{B8B7B27E-5BCE-3D6A-9FDB-F6BDB25AE0D1}"/>
               </a:ext>
             </a:extLst>
           </p:cNvPr>
@@ -6703,7 +6703,7 @@
           <p:cNvPr id="41" name="Connettore 2 40">
             <a:extLst>
               <a:ext uri="{FF2B5EF4-FFF2-40B4-BE49-F238E27FC236}">
-                <a16:creationId xmlns:a16="http://schemas.microsoft.com/office/drawing/2014/main" xmlns="" id="{E08D2448-CE81-166A-D3ED-5BE657222BBD}"/>
+                <a16:creationId xmlns="" xmlns:a16="http://schemas.microsoft.com/office/drawing/2014/main" id="{E08D2448-CE81-166A-D3ED-5BE657222BBD}"/>
               </a:ext>
             </a:extLst>
           </p:cNvPr>
@@ -6748,7 +6748,7 @@
           <p:cNvPr id="43" name="Arco 42">
             <a:extLst>
               <a:ext uri="{FF2B5EF4-FFF2-40B4-BE49-F238E27FC236}">
-                <a16:creationId xmlns:a16="http://schemas.microsoft.com/office/drawing/2014/main" xmlns="" id="{20F56D05-B862-913A-2667-E5DBA12B9C1E}"/>
+                <a16:creationId xmlns="" xmlns:a16="http://schemas.microsoft.com/office/drawing/2014/main" id="{20F56D05-B862-913A-2667-E5DBA12B9C1E}"/>
               </a:ext>
             </a:extLst>
           </p:cNvPr>
@@ -6833,7 +6833,7 @@
           <p:cNvPr id="4" name="CasellaDiTesto 5">
             <a:extLst>
               <a:ext uri="{FF2B5EF4-FFF2-40B4-BE49-F238E27FC236}">
-                <a16:creationId xmlns:a16="http://schemas.microsoft.com/office/drawing/2014/main" xmlns="" id="{CEC292C3-EA43-E807-C5E9-121AC71FFD98}"/>
+                <a16:creationId xmlns="" xmlns:a16="http://schemas.microsoft.com/office/drawing/2014/main" id="{CEC292C3-EA43-E807-C5E9-121AC71FFD98}"/>
               </a:ext>
             </a:extLst>
           </p:cNvPr>
@@ -7706,7 +7706,7 @@
           <p:cNvPr id="5" name="Parentesi quadra chiusa 4">
             <a:extLst>
               <a:ext uri="{FF2B5EF4-FFF2-40B4-BE49-F238E27FC236}">
-                <a16:creationId xmlns:a16="http://schemas.microsoft.com/office/drawing/2014/main" xmlns="" id="{4CAF5ACA-349E-1600-F45E-541FEFB11A1E}"/>
+                <a16:creationId xmlns="" xmlns:a16="http://schemas.microsoft.com/office/drawing/2014/main" id="{4CAF5ACA-349E-1600-F45E-541FEFB11A1E}"/>
               </a:ext>
             </a:extLst>
           </p:cNvPr>
@@ -7759,7 +7759,7 @@
           <p:cNvPr id="6" name="Parentesi quadra chiusa 5">
             <a:extLst>
               <a:ext uri="{FF2B5EF4-FFF2-40B4-BE49-F238E27FC236}">
-                <a16:creationId xmlns:a16="http://schemas.microsoft.com/office/drawing/2014/main" xmlns="" id="{CBFD60EB-6ECF-3710-A057-AE80821C9EC1}"/>
+                <a16:creationId xmlns="" xmlns:a16="http://schemas.microsoft.com/office/drawing/2014/main" id="{CBFD60EB-6ECF-3710-A057-AE80821C9EC1}"/>
               </a:ext>
             </a:extLst>
           </p:cNvPr>
@@ -7808,7 +7808,7 @@
           <p:cNvPr id="7" name="Parentesi quadra chiusa 6">
             <a:extLst>
               <a:ext uri="{FF2B5EF4-FFF2-40B4-BE49-F238E27FC236}">
-                <a16:creationId xmlns:a16="http://schemas.microsoft.com/office/drawing/2014/main" xmlns="" id="{CA4892F2-6921-CD41-D2F0-4E04D3959A09}"/>
+                <a16:creationId xmlns="" xmlns:a16="http://schemas.microsoft.com/office/drawing/2014/main" id="{CA4892F2-6921-CD41-D2F0-4E04D3959A09}"/>
               </a:ext>
             </a:extLst>
           </p:cNvPr>
@@ -7857,7 +7857,7 @@
           <p:cNvPr id="8" name="CasellaDiTesto 7">
             <a:extLst>
               <a:ext uri="{FF2B5EF4-FFF2-40B4-BE49-F238E27FC236}">
-                <a16:creationId xmlns:a16="http://schemas.microsoft.com/office/drawing/2014/main" xmlns="" id="{75707DB5-3D6C-FBFA-3C15-A3A51E4184EF}"/>
+                <a16:creationId xmlns="" xmlns:a16="http://schemas.microsoft.com/office/drawing/2014/main" id="{75707DB5-3D6C-FBFA-3C15-A3A51E4184EF}"/>
               </a:ext>
             </a:extLst>
           </p:cNvPr>
@@ -7893,7 +7893,7 @@
           <p:cNvPr id="14" name="CasellaDiTesto 13">
             <a:extLst>
               <a:ext uri="{FF2B5EF4-FFF2-40B4-BE49-F238E27FC236}">
-                <a16:creationId xmlns:a16="http://schemas.microsoft.com/office/drawing/2014/main" xmlns="" id="{DAA0988F-D3EB-D6CD-09BC-C751D9459103}"/>
+                <a16:creationId xmlns="" xmlns:a16="http://schemas.microsoft.com/office/drawing/2014/main" id="{DAA0988F-D3EB-D6CD-09BC-C751D9459103}"/>
               </a:ext>
             </a:extLst>
           </p:cNvPr>
@@ -7928,7 +7928,7 @@
           <p:cNvPr id="15" name="CasellaDiTesto 14">
             <a:extLst>
               <a:ext uri="{FF2B5EF4-FFF2-40B4-BE49-F238E27FC236}">
-                <a16:creationId xmlns:a16="http://schemas.microsoft.com/office/drawing/2014/main" xmlns="" id="{F38C0947-6DCB-D6DB-E7B1-50E22295DB53}"/>
+                <a16:creationId xmlns="" xmlns:a16="http://schemas.microsoft.com/office/drawing/2014/main" id="{F38C0947-6DCB-D6DB-E7B1-50E22295DB53}"/>
               </a:ext>
             </a:extLst>
           </p:cNvPr>
@@ -7964,7 +7964,7 @@
           <p:cNvPr id="16" name="CasellaDiTesto 15">
             <a:extLst>
               <a:ext uri="{FF2B5EF4-FFF2-40B4-BE49-F238E27FC236}">
-                <a16:creationId xmlns:a16="http://schemas.microsoft.com/office/drawing/2014/main" xmlns="" id="{FE50E7B8-FF35-944A-EF5B-2D92DE85758A}"/>
+                <a16:creationId xmlns="" xmlns:a16="http://schemas.microsoft.com/office/drawing/2014/main" id="{FE50E7B8-FF35-944A-EF5B-2D92DE85758A}"/>
               </a:ext>
             </a:extLst>
           </p:cNvPr>
@@ -8005,7 +8005,7 @@
           <p:cNvPr id="18" name="Connettore 2 17">
             <a:extLst>
               <a:ext uri="{FF2B5EF4-FFF2-40B4-BE49-F238E27FC236}">
-                <a16:creationId xmlns:a16="http://schemas.microsoft.com/office/drawing/2014/main" xmlns="" id="{CE5B284D-1B9D-A770-3C08-12B300E14885}"/>
+                <a16:creationId xmlns="" xmlns:a16="http://schemas.microsoft.com/office/drawing/2014/main" id="{CE5B284D-1B9D-A770-3C08-12B300E14885}"/>
               </a:ext>
             </a:extLst>
           </p:cNvPr>
@@ -8051,7 +8051,7 @@
           <p:cNvPr id="19" name="Connettore 2 18">
             <a:extLst>
               <a:ext uri="{FF2B5EF4-FFF2-40B4-BE49-F238E27FC236}">
-                <a16:creationId xmlns:a16="http://schemas.microsoft.com/office/drawing/2014/main" xmlns="" id="{799D989F-CD78-A709-0F79-043C93D14C7F}"/>
+                <a16:creationId xmlns="" xmlns:a16="http://schemas.microsoft.com/office/drawing/2014/main" id="{799D989F-CD78-A709-0F79-043C93D14C7F}"/>
               </a:ext>
             </a:extLst>
           </p:cNvPr>
@@ -8097,7 +8097,7 @@
           <p:cNvPr id="22" name="Connettore 2 21">
             <a:extLst>
               <a:ext uri="{FF2B5EF4-FFF2-40B4-BE49-F238E27FC236}">
-                <a16:creationId xmlns:a16="http://schemas.microsoft.com/office/drawing/2014/main" xmlns="" id="{6775320F-145D-6061-12D0-BCEE6EB8B531}"/>
+                <a16:creationId xmlns="" xmlns:a16="http://schemas.microsoft.com/office/drawing/2014/main" id="{6775320F-145D-6061-12D0-BCEE6EB8B531}"/>
               </a:ext>
             </a:extLst>
           </p:cNvPr>
@@ -8143,7 +8143,7 @@
           <p:cNvPr id="40" name="Freccia in su 39">
             <a:extLst>
               <a:ext uri="{FF2B5EF4-FFF2-40B4-BE49-F238E27FC236}">
-                <a16:creationId xmlns:a16="http://schemas.microsoft.com/office/drawing/2014/main" xmlns="" id="{3712E528-00DA-4B02-DE16-F591A205E7EF}"/>
+                <a16:creationId xmlns="" xmlns:a16="http://schemas.microsoft.com/office/drawing/2014/main" id="{3712E528-00DA-4B02-DE16-F591A205E7EF}"/>
               </a:ext>
             </a:extLst>
           </p:cNvPr>
@@ -8192,7 +8192,7 @@
           <p:cNvPr id="41" name="Freccia in su 40">
             <a:extLst>
               <a:ext uri="{FF2B5EF4-FFF2-40B4-BE49-F238E27FC236}">
-                <a16:creationId xmlns:a16="http://schemas.microsoft.com/office/drawing/2014/main" xmlns="" id="{90EDC1D3-FBA8-2D56-A543-C7AEBBDCB7D4}"/>
+                <a16:creationId xmlns="" xmlns:a16="http://schemas.microsoft.com/office/drawing/2014/main" id="{90EDC1D3-FBA8-2D56-A543-C7AEBBDCB7D4}"/>
               </a:ext>
             </a:extLst>
           </p:cNvPr>
@@ -8251,7 +8251,7 @@
   </p:transition>
   <p:extLst mod="1">
     <p:ext uri="{6950BFC3-D8DA-4A85-94F7-54DA5524770B}">
-      <p188:commentRel xmlns:p188="http://schemas.microsoft.com/office/powerpoint/2018/8/main" xmlns="" r:id="rId2"/>
+      <p188:commentRel xmlns="" xmlns:p188="http://schemas.microsoft.com/office/powerpoint/2018/8/main" r:id="rId2"/>
     </p:ext>
   </p:extLst>
 </p:sld>
@@ -8279,7 +8279,7 @@
           <p:cNvPr id="12" name="Tabella 11">
             <a:extLst>
               <a:ext uri="{FF2B5EF4-FFF2-40B4-BE49-F238E27FC236}">
-                <a16:creationId xmlns:a16="http://schemas.microsoft.com/office/drawing/2014/main" xmlns="" id="{A1ACA96F-FB52-FDAA-1EF6-CEF470E2DFEE}"/>
+                <a16:creationId xmlns="" xmlns:a16="http://schemas.microsoft.com/office/drawing/2014/main" id="{A1ACA96F-FB52-FDAA-1EF6-CEF470E2DFEE}"/>
               </a:ext>
             </a:extLst>
           </p:cNvPr>
@@ -8308,28 +8308,28 @@
                 <a:gridCol w="859972">
                   <a:extLst>
                     <a:ext uri="{9D8B030D-6E8A-4147-A177-3AD203B41FA5}">
-                      <a16:colId xmlns:a16="http://schemas.microsoft.com/office/drawing/2014/main" xmlns="" val="4284198487"/>
+                      <a16:colId xmlns="" xmlns:a16="http://schemas.microsoft.com/office/drawing/2014/main" val="4284198487"/>
                     </a:ext>
                   </a:extLst>
                 </a:gridCol>
                 <a:gridCol w="3627664">
                   <a:extLst>
                     <a:ext uri="{9D8B030D-6E8A-4147-A177-3AD203B41FA5}">
-                      <a16:colId xmlns:a16="http://schemas.microsoft.com/office/drawing/2014/main" xmlns="" val="1109357295"/>
+                      <a16:colId xmlns="" xmlns:a16="http://schemas.microsoft.com/office/drawing/2014/main" val="1109357295"/>
                     </a:ext>
                   </a:extLst>
                 </a:gridCol>
                 <a:gridCol w="3695700">
                   <a:extLst>
                     <a:ext uri="{9D8B030D-6E8A-4147-A177-3AD203B41FA5}">
-                      <a16:colId xmlns:a16="http://schemas.microsoft.com/office/drawing/2014/main" xmlns="" val="2215651560"/>
+                      <a16:colId xmlns="" xmlns:a16="http://schemas.microsoft.com/office/drawing/2014/main" val="2215651560"/>
                     </a:ext>
                   </a:extLst>
                 </a:gridCol>
                 <a:gridCol w="3733799">
                   <a:extLst>
                     <a:ext uri="{9D8B030D-6E8A-4147-A177-3AD203B41FA5}">
-                      <a16:colId xmlns:a16="http://schemas.microsoft.com/office/drawing/2014/main" xmlns="" val="35324255"/>
+                      <a16:colId xmlns="" xmlns:a16="http://schemas.microsoft.com/office/drawing/2014/main" val="35324255"/>
                     </a:ext>
                   </a:extLst>
                 </a:gridCol>
@@ -8422,7 +8422,7 @@
                 </a:tc>
                 <a:extLst>
                   <a:ext uri="{0D108BD9-81ED-4DB2-BD59-A6C34878D82A}">
-                    <a16:rowId xmlns:a16="http://schemas.microsoft.com/office/drawing/2014/main" xmlns="" val="987328508"/>
+                    <a16:rowId xmlns="" xmlns:a16="http://schemas.microsoft.com/office/drawing/2014/main" val="987328508"/>
                   </a:ext>
                 </a:extLst>
               </a:tr>
@@ -8496,7 +8496,7 @@
                 </a:tc>
                 <a:extLst>
                   <a:ext uri="{0D108BD9-81ED-4DB2-BD59-A6C34878D82A}">
-                    <a16:rowId xmlns:a16="http://schemas.microsoft.com/office/drawing/2014/main" xmlns="" val="2382391448"/>
+                    <a16:rowId xmlns="" xmlns:a16="http://schemas.microsoft.com/office/drawing/2014/main" val="2382391448"/>
                   </a:ext>
                 </a:extLst>
               </a:tr>
@@ -8570,7 +8570,7 @@
                 </a:tc>
                 <a:extLst>
                   <a:ext uri="{0D108BD9-81ED-4DB2-BD59-A6C34878D82A}">
-                    <a16:rowId xmlns:a16="http://schemas.microsoft.com/office/drawing/2014/main" xmlns="" val="460792091"/>
+                    <a16:rowId xmlns="" xmlns:a16="http://schemas.microsoft.com/office/drawing/2014/main" val="460792091"/>
                   </a:ext>
                 </a:extLst>
               </a:tr>
@@ -8583,7 +8583,7 @@
           <p:cNvPr id="11" name="CasellaDiTesto 10">
             <a:extLst>
               <a:ext uri="{FF2B5EF4-FFF2-40B4-BE49-F238E27FC236}">
-                <a16:creationId xmlns:a16="http://schemas.microsoft.com/office/drawing/2014/main" xmlns="" id="{A94044C0-64FE-67A3-08DC-1284418CAA69}"/>
+                <a16:creationId xmlns="" xmlns:a16="http://schemas.microsoft.com/office/drawing/2014/main" id="{A94044C0-64FE-67A3-08DC-1284418CAA69}"/>
               </a:ext>
             </a:extLst>
           </p:cNvPr>
@@ -8624,7 +8624,7 @@
           <p:cNvPr id="21" name="Immagine 20" descr="Immagine che contiene testo, schermata, Diagramma, linea&#10;&#10;Il contenuto generato dall'IA potrebbe non essere corretto.">
             <a:extLst>
               <a:ext uri="{FF2B5EF4-FFF2-40B4-BE49-F238E27FC236}">
-                <a16:creationId xmlns:a16="http://schemas.microsoft.com/office/drawing/2014/main" xmlns="" id="{E359F701-5803-2876-51ED-345272814C99}"/>
+                <a16:creationId xmlns="" xmlns:a16="http://schemas.microsoft.com/office/drawing/2014/main" id="{E359F701-5803-2876-51ED-345272814C99}"/>
               </a:ext>
             </a:extLst>
           </p:cNvPr>
@@ -8660,7 +8660,7 @@
           <p:cNvPr id="23" name="Immagine 22" descr="Immagine che contiene testo, Diagramma, schermata, linea&#10;&#10;Il contenuto generato dall'IA potrebbe non essere corretto.">
             <a:extLst>
               <a:ext uri="{FF2B5EF4-FFF2-40B4-BE49-F238E27FC236}">
-                <a16:creationId xmlns:a16="http://schemas.microsoft.com/office/drawing/2014/main" xmlns="" id="{151FB383-93D1-A085-240A-40E09860E8D4}"/>
+                <a16:creationId xmlns="" xmlns:a16="http://schemas.microsoft.com/office/drawing/2014/main" id="{151FB383-93D1-A085-240A-40E09860E8D4}"/>
               </a:ext>
             </a:extLst>
           </p:cNvPr>
@@ -8696,7 +8696,7 @@
           <p:cNvPr id="25" name="Immagine 24" descr="Immagine che contiene testo, diagramma, Diagramma, schermata&#10;&#10;Il contenuto generato dall'IA potrebbe non essere corretto.">
             <a:extLst>
               <a:ext uri="{FF2B5EF4-FFF2-40B4-BE49-F238E27FC236}">
-                <a16:creationId xmlns:a16="http://schemas.microsoft.com/office/drawing/2014/main" xmlns="" id="{E2F5881F-7F5D-2677-01EF-22ADBC9C3D93}"/>
+                <a16:creationId xmlns="" xmlns:a16="http://schemas.microsoft.com/office/drawing/2014/main" id="{E2F5881F-7F5D-2677-01EF-22ADBC9C3D93}"/>
               </a:ext>
             </a:extLst>
           </p:cNvPr>
@@ -8732,7 +8732,7 @@
           <p:cNvPr id="27" name="Immagine 26" descr="Immagine che contiene Diagramma, diagramma, testo, linea&#10;&#10;Il contenuto generato dall'IA potrebbe non essere corretto.">
             <a:extLst>
               <a:ext uri="{FF2B5EF4-FFF2-40B4-BE49-F238E27FC236}">
-                <a16:creationId xmlns:a16="http://schemas.microsoft.com/office/drawing/2014/main" xmlns="" id="{CC489984-BBAD-4BB8-5AD1-E108A119B320}"/>
+                <a16:creationId xmlns="" xmlns:a16="http://schemas.microsoft.com/office/drawing/2014/main" id="{CC489984-BBAD-4BB8-5AD1-E108A119B320}"/>
               </a:ext>
             </a:extLst>
           </p:cNvPr>
@@ -8768,7 +8768,7 @@
           <p:cNvPr id="29" name="Immagine 28" descr="Immagine che contiene linea, diagramma, Diagramma, schermata&#10;&#10;Il contenuto generato dall'IA potrebbe non essere corretto.">
             <a:extLst>
               <a:ext uri="{FF2B5EF4-FFF2-40B4-BE49-F238E27FC236}">
-                <a16:creationId xmlns:a16="http://schemas.microsoft.com/office/drawing/2014/main" xmlns="" id="{73AF8E5B-688B-8721-2C69-36B948BB6CC5}"/>
+                <a16:creationId xmlns="" xmlns:a16="http://schemas.microsoft.com/office/drawing/2014/main" id="{73AF8E5B-688B-8721-2C69-36B948BB6CC5}"/>
               </a:ext>
             </a:extLst>
           </p:cNvPr>
@@ -8804,7 +8804,7 @@
           <p:cNvPr id="31" name="Immagine 30" descr="Immagine che contiene testo, diagramma, Diagramma, linea&#10;&#10;Il contenuto generato dall'IA potrebbe non essere corretto.">
             <a:extLst>
               <a:ext uri="{FF2B5EF4-FFF2-40B4-BE49-F238E27FC236}">
-                <a16:creationId xmlns:a16="http://schemas.microsoft.com/office/drawing/2014/main" xmlns="" id="{89DD8777-05EB-8491-41C8-1FA0C861299E}"/>
+                <a16:creationId xmlns="" xmlns:a16="http://schemas.microsoft.com/office/drawing/2014/main" id="{89DD8777-05EB-8491-41C8-1FA0C861299E}"/>
               </a:ext>
             </a:extLst>
           </p:cNvPr>
@@ -8840,7 +8840,7 @@
           <p:cNvPr id="33" name="Connettore diritto 32">
             <a:extLst>
               <a:ext uri="{FF2B5EF4-FFF2-40B4-BE49-F238E27FC236}">
-                <a16:creationId xmlns:a16="http://schemas.microsoft.com/office/drawing/2014/main" xmlns="" id="{C5E9E799-9261-70BE-9933-BA23738C1A3C}"/>
+                <a16:creationId xmlns="" xmlns:a16="http://schemas.microsoft.com/office/drawing/2014/main" id="{C5E9E799-9261-70BE-9933-BA23738C1A3C}"/>
               </a:ext>
             </a:extLst>
           </p:cNvPr>
@@ -8885,7 +8885,7 @@
               <p:cNvPr id="39" name="CasellaDiTesto 38">
                 <a:extLst>
                   <a:ext uri="{FF2B5EF4-FFF2-40B4-BE49-F238E27FC236}">
-                    <a16:creationId xmlns:a16="http://schemas.microsoft.com/office/drawing/2014/main" xmlns="" id="{F884DB21-C8B3-0EE1-2525-D6FFF4280A95}"/>
+                    <a16:creationId xmlns="" xmlns:a16="http://schemas.microsoft.com/office/drawing/2014/main" id="{F884DB21-C8B3-0EE1-2525-D6FFF4280A95}"/>
                   </a:ext>
                 </a:extLst>
               </p:cNvPr>
@@ -9013,7 +9013,7 @@
               <p:cNvPr id="41" name="CasellaDiTesto 40">
                 <a:extLst>
                   <a:ext uri="{FF2B5EF4-FFF2-40B4-BE49-F238E27FC236}">
-                    <a16:creationId xmlns:a16="http://schemas.microsoft.com/office/drawing/2014/main" xmlns="" id="{1B4DD944-AC74-215B-5688-FB9AB527D5AC}"/>
+                    <a16:creationId xmlns="" xmlns:a16="http://schemas.microsoft.com/office/drawing/2014/main" id="{1B4DD944-AC74-215B-5688-FB9AB527D5AC}"/>
                   </a:ext>
                 </a:extLst>
               </p:cNvPr>
@@ -9172,7 +9172,7 @@
           <p:cNvPr id="10" name="CasellaDiTesto 9">
             <a:extLst>
               <a:ext uri="{FF2B5EF4-FFF2-40B4-BE49-F238E27FC236}">
-                <a16:creationId xmlns:a16="http://schemas.microsoft.com/office/drawing/2014/main" xmlns="" id="{D8CB4029-D919-CBE6-16F5-21ABE5FB2AAD}"/>
+                <a16:creationId xmlns="" xmlns:a16="http://schemas.microsoft.com/office/drawing/2014/main" id="{D8CB4029-D919-CBE6-16F5-21ABE5FB2AAD}"/>
               </a:ext>
             </a:extLst>
           </p:cNvPr>
@@ -9213,7 +9213,7 @@
           <p:cNvPr id="12" name="Immagine 11">
             <a:extLst>
               <a:ext uri="{FF2B5EF4-FFF2-40B4-BE49-F238E27FC236}">
-                <a16:creationId xmlns:a16="http://schemas.microsoft.com/office/drawing/2014/main" xmlns="" id="{B7D9DC9B-7AC9-022F-BF02-DB76F98DE0D1}"/>
+                <a16:creationId xmlns="" xmlns:a16="http://schemas.microsoft.com/office/drawing/2014/main" id="{B7D9DC9B-7AC9-022F-BF02-DB76F98DE0D1}"/>
               </a:ext>
             </a:extLst>
           </p:cNvPr>
@@ -9241,7 +9241,7 @@
           <p:cNvPr id="13" name="Immagine 12">
             <a:extLst>
               <a:ext uri="{FF2B5EF4-FFF2-40B4-BE49-F238E27FC236}">
-                <a16:creationId xmlns:a16="http://schemas.microsoft.com/office/drawing/2014/main" xmlns="" id="{F6B36572-95CE-6C2A-D789-820675964661}"/>
+                <a16:creationId xmlns="" xmlns:a16="http://schemas.microsoft.com/office/drawing/2014/main" id="{F6B36572-95CE-6C2A-D789-820675964661}"/>
               </a:ext>
             </a:extLst>
           </p:cNvPr>
@@ -9269,7 +9269,7 @@
           <p:cNvPr id="14" name="CasellaDiTesto 13">
             <a:extLst>
               <a:ext uri="{FF2B5EF4-FFF2-40B4-BE49-F238E27FC236}">
-                <a16:creationId xmlns:a16="http://schemas.microsoft.com/office/drawing/2014/main" xmlns="" id="{61E3F021-CC1A-4EAE-C4A5-CC7EBEABAE52}"/>
+                <a16:creationId xmlns="" xmlns:a16="http://schemas.microsoft.com/office/drawing/2014/main" id="{61E3F021-CC1A-4EAE-C4A5-CC7EBEABAE52}"/>
               </a:ext>
             </a:extLst>
           </p:cNvPr>
@@ -9304,7 +9304,7 @@
           <p:cNvPr id="15" name="Connettore 2 14">
             <a:extLst>
               <a:ext uri="{FF2B5EF4-FFF2-40B4-BE49-F238E27FC236}">
-                <a16:creationId xmlns:a16="http://schemas.microsoft.com/office/drawing/2014/main" xmlns="" id="{302592CC-E767-65B2-821E-0D8067D224CE}"/>
+                <a16:creationId xmlns="" xmlns:a16="http://schemas.microsoft.com/office/drawing/2014/main" id="{302592CC-E767-65B2-821E-0D8067D224CE}"/>
               </a:ext>
             </a:extLst>
           </p:cNvPr>
@@ -9348,7 +9348,7 @@
           <p:cNvPr id="17" name="Connettore 2 16">
             <a:extLst>
               <a:ext uri="{FF2B5EF4-FFF2-40B4-BE49-F238E27FC236}">
-                <a16:creationId xmlns:a16="http://schemas.microsoft.com/office/drawing/2014/main" xmlns="" id="{29B40A2C-A49D-D2DE-B18D-FD434A548BD4}"/>
+                <a16:creationId xmlns="" xmlns:a16="http://schemas.microsoft.com/office/drawing/2014/main" id="{29B40A2C-A49D-D2DE-B18D-FD434A548BD4}"/>
               </a:ext>
             </a:extLst>
           </p:cNvPr>
@@ -9392,7 +9392,7 @@
           <p:cNvPr id="18" name="Connettore 2 17">
             <a:extLst>
               <a:ext uri="{FF2B5EF4-FFF2-40B4-BE49-F238E27FC236}">
-                <a16:creationId xmlns:a16="http://schemas.microsoft.com/office/drawing/2014/main" xmlns="" id="{E09CA786-8E9B-E78D-FCA8-396C337BA892}"/>
+                <a16:creationId xmlns="" xmlns:a16="http://schemas.microsoft.com/office/drawing/2014/main" id="{E09CA786-8E9B-E78D-FCA8-396C337BA892}"/>
               </a:ext>
             </a:extLst>
           </p:cNvPr>
@@ -9436,7 +9436,7 @@
           <p:cNvPr id="22" name="CasellaDiTesto 21">
             <a:extLst>
               <a:ext uri="{FF2B5EF4-FFF2-40B4-BE49-F238E27FC236}">
-                <a16:creationId xmlns:a16="http://schemas.microsoft.com/office/drawing/2014/main" xmlns="" id="{55EBC8D6-2EEF-73D6-B302-378262721507}"/>
+                <a16:creationId xmlns="" xmlns:a16="http://schemas.microsoft.com/office/drawing/2014/main" id="{55EBC8D6-2EEF-73D6-B302-378262721507}"/>
               </a:ext>
             </a:extLst>
           </p:cNvPr>
@@ -9471,7 +9471,7 @@
           <p:cNvPr id="24" name="Immagine 23" descr="Immagine che contiene testo, schermata, linea, Carattere&#10;&#10;Il contenuto generato dall'IA potrebbe non essere corretto.">
             <a:extLst>
               <a:ext uri="{FF2B5EF4-FFF2-40B4-BE49-F238E27FC236}">
-                <a16:creationId xmlns:a16="http://schemas.microsoft.com/office/drawing/2014/main" xmlns="" id="{F200B2F0-2031-4309-044E-8729D334BB57}"/>
+                <a16:creationId xmlns="" xmlns:a16="http://schemas.microsoft.com/office/drawing/2014/main" id="{F200B2F0-2031-4309-044E-8729D334BB57}"/>
               </a:ext>
             </a:extLst>
           </p:cNvPr>
@@ -9507,7 +9507,7 @@
           <p:cNvPr id="25" name="Immagine 24">
             <a:extLst>
               <a:ext uri="{FF2B5EF4-FFF2-40B4-BE49-F238E27FC236}">
-                <a16:creationId xmlns:a16="http://schemas.microsoft.com/office/drawing/2014/main" xmlns="" id="{E617AD09-F8C6-53E6-E9C3-654431F34B45}"/>
+                <a16:creationId xmlns="" xmlns:a16="http://schemas.microsoft.com/office/drawing/2014/main" id="{E617AD09-F8C6-53E6-E9C3-654431F34B45}"/>
               </a:ext>
             </a:extLst>
           </p:cNvPr>
@@ -9537,7 +9537,7 @@
           <p:cNvPr id="26" name="CasellaDiTesto 25">
             <a:extLst>
               <a:ext uri="{FF2B5EF4-FFF2-40B4-BE49-F238E27FC236}">
-                <a16:creationId xmlns:a16="http://schemas.microsoft.com/office/drawing/2014/main" xmlns="" id="{46E1D517-77BF-F8F7-3F5C-FE635EDA1969}"/>
+                <a16:creationId xmlns="" xmlns:a16="http://schemas.microsoft.com/office/drawing/2014/main" id="{46E1D517-77BF-F8F7-3F5C-FE635EDA1969}"/>
               </a:ext>
             </a:extLst>
           </p:cNvPr>
@@ -9577,7 +9577,7 @@
           <p:cNvPr id="27" name="CasellaDiTesto 26">
             <a:extLst>
               <a:ext uri="{FF2B5EF4-FFF2-40B4-BE49-F238E27FC236}">
-                <a16:creationId xmlns:a16="http://schemas.microsoft.com/office/drawing/2014/main" xmlns="" id="{D2C4C065-A295-5C57-6DF8-4FCCD4BC0B27}"/>
+                <a16:creationId xmlns="" xmlns:a16="http://schemas.microsoft.com/office/drawing/2014/main" id="{D2C4C065-A295-5C57-6DF8-4FCCD4BC0B27}"/>
               </a:ext>
             </a:extLst>
           </p:cNvPr>
@@ -9633,7 +9633,7 @@
           <p:cNvPr id="28" name="CasellaDiTesto 27">
             <a:extLst>
               <a:ext uri="{FF2B5EF4-FFF2-40B4-BE49-F238E27FC236}">
-                <a16:creationId xmlns:a16="http://schemas.microsoft.com/office/drawing/2014/main" xmlns="" id="{8AB45177-CB35-3AF1-A37A-0CF7EF1A439D}"/>
+                <a16:creationId xmlns="" xmlns:a16="http://schemas.microsoft.com/office/drawing/2014/main" id="{8AB45177-CB35-3AF1-A37A-0CF7EF1A439D}"/>
               </a:ext>
             </a:extLst>
           </p:cNvPr>
@@ -9689,7 +9689,7 @@
           <p:cNvPr id="29" name="CasellaDiTesto 28">
             <a:extLst>
               <a:ext uri="{FF2B5EF4-FFF2-40B4-BE49-F238E27FC236}">
-                <a16:creationId xmlns:a16="http://schemas.microsoft.com/office/drawing/2014/main" xmlns="" id="{A3923560-2D06-ED04-E8C1-47CA2364E477}"/>
+                <a16:creationId xmlns="" xmlns:a16="http://schemas.microsoft.com/office/drawing/2014/main" id="{A3923560-2D06-ED04-E8C1-47CA2364E477}"/>
               </a:ext>
             </a:extLst>
           </p:cNvPr>
@@ -9763,7 +9763,7 @@
           <p:cNvPr id="4" name="CasellaDiTesto 3">
             <a:extLst>
               <a:ext uri="{FF2B5EF4-FFF2-40B4-BE49-F238E27FC236}">
-                <a16:creationId xmlns:a16="http://schemas.microsoft.com/office/drawing/2014/main" xmlns="" id="{9EC0439B-A3B5-C363-09AB-021E5450AFF1}"/>
+                <a16:creationId xmlns="" xmlns:a16="http://schemas.microsoft.com/office/drawing/2014/main" id="{9EC0439B-A3B5-C363-09AB-021E5450AFF1}"/>
               </a:ext>
             </a:extLst>
           </p:cNvPr>
@@ -10176,7 +10176,7 @@
           <p:cNvPr id="7" name="Parentesi quadra chiusa 6">
             <a:extLst>
               <a:ext uri="{FF2B5EF4-FFF2-40B4-BE49-F238E27FC236}">
-                <a16:creationId xmlns:a16="http://schemas.microsoft.com/office/drawing/2014/main" xmlns="" id="{52EC2C8F-62FF-6213-90C5-57FBFEB1F28D}"/>
+                <a16:creationId xmlns="" xmlns:a16="http://schemas.microsoft.com/office/drawing/2014/main" id="{52EC2C8F-62FF-6213-90C5-57FBFEB1F28D}"/>
               </a:ext>
             </a:extLst>
           </p:cNvPr>
@@ -10220,14 +10220,14 @@
           </a:p>
         </p:txBody>
       </p:sp>
-      <mc:AlternateContent xmlns:mc="http://schemas.openxmlformats.org/markup-compatibility/2006">
-        <mc:Choice xmlns:a14="http://schemas.microsoft.com/office/drawing/2010/main" Requires="a14">
+      <mc:AlternateContent xmlns:mc="http://schemas.openxmlformats.org/markup-compatibility/2006" xmlns:a14="http://schemas.microsoft.com/office/drawing/2010/main">
+        <mc:Choice Requires="a14">
           <p:sp>
             <p:nvSpPr>
               <p:cNvPr id="11" name="CasellaDiTesto 10">
                 <a:extLst>
                   <a:ext uri="{FF2B5EF4-FFF2-40B4-BE49-F238E27FC236}">
-                    <a16:creationId xmlns:a16="http://schemas.microsoft.com/office/drawing/2014/main" xmlns="" id="{FB83B6F9-33E1-031F-1F2C-A0735F6B3587}"/>
+                    <a16:creationId xmlns="" xmlns:a16="http://schemas.microsoft.com/office/drawing/2014/main" id="{FB83B6F9-33E1-031F-1F2C-A0735F6B3587}"/>
                   </a:ext>
                 </a:extLst>
               </p:cNvPr>
@@ -10409,7 +10409,7 @@
             </p:txBody>
           </p:sp>
         </mc:Choice>
-        <mc:Fallback>
+        <mc:Fallback xmlns="">
           <p:sp>
             <p:nvSpPr>
               <p:cNvPr id="11" name="CasellaDiTesto 10">
@@ -10459,7 +10459,7 @@
           <p:cNvPr id="13" name="Connettore 2 12">
             <a:extLst>
               <a:ext uri="{FF2B5EF4-FFF2-40B4-BE49-F238E27FC236}">
-                <a16:creationId xmlns:a16="http://schemas.microsoft.com/office/drawing/2014/main" xmlns="" id="{AC1217CC-9448-E2A9-D533-4A7930B29BEE}"/>
+                <a16:creationId xmlns="" xmlns:a16="http://schemas.microsoft.com/office/drawing/2014/main" id="{AC1217CC-9448-E2A9-D533-4A7930B29BEE}"/>
               </a:ext>
             </a:extLst>
           </p:cNvPr>
@@ -10505,7 +10505,7 @@
           <p:cNvPr id="20" name="Parentesi quadra chiusa 19">
             <a:extLst>
               <a:ext uri="{FF2B5EF4-FFF2-40B4-BE49-F238E27FC236}">
-                <a16:creationId xmlns:a16="http://schemas.microsoft.com/office/drawing/2014/main" xmlns="" id="{9019E1D3-65F8-5818-B40E-1B93C9A07069}"/>
+                <a16:creationId xmlns="" xmlns:a16="http://schemas.microsoft.com/office/drawing/2014/main" id="{9019E1D3-65F8-5818-B40E-1B93C9A07069}"/>
               </a:ext>
             </a:extLst>
           </p:cNvPr>
@@ -10554,7 +10554,7 @@
           <p:cNvPr id="21" name="CasellaDiTesto 20">
             <a:extLst>
               <a:ext uri="{FF2B5EF4-FFF2-40B4-BE49-F238E27FC236}">
-                <a16:creationId xmlns:a16="http://schemas.microsoft.com/office/drawing/2014/main" xmlns="" id="{6F854F06-21BE-D0AF-5409-ECB3A730B0BD}"/>
+                <a16:creationId xmlns="" xmlns:a16="http://schemas.microsoft.com/office/drawing/2014/main" id="{6F854F06-21BE-D0AF-5409-ECB3A730B0BD}"/>
               </a:ext>
             </a:extLst>
           </p:cNvPr>
@@ -10590,7 +10590,7 @@
           <p:cNvPr id="22" name="Connettore 2 21">
             <a:extLst>
               <a:ext uri="{FF2B5EF4-FFF2-40B4-BE49-F238E27FC236}">
-                <a16:creationId xmlns:a16="http://schemas.microsoft.com/office/drawing/2014/main" xmlns="" id="{AD8B6639-65AF-3D38-A2D3-3D8AC2FA9EC8}"/>
+                <a16:creationId xmlns="" xmlns:a16="http://schemas.microsoft.com/office/drawing/2014/main" id="{AD8B6639-65AF-3D38-A2D3-3D8AC2FA9EC8}"/>
               </a:ext>
             </a:extLst>
           </p:cNvPr>
@@ -10636,7 +10636,7 @@
           <p:cNvPr id="23" name="CasellaDiTesto 22">
             <a:extLst>
               <a:ext uri="{FF2B5EF4-FFF2-40B4-BE49-F238E27FC236}">
-                <a16:creationId xmlns:a16="http://schemas.microsoft.com/office/drawing/2014/main" xmlns="" id="{79F82AE0-D198-EE52-C7B1-AFE88A0ECC06}"/>
+                <a16:creationId xmlns="" xmlns:a16="http://schemas.microsoft.com/office/drawing/2014/main" id="{79F82AE0-D198-EE52-C7B1-AFE88A0ECC06}"/>
               </a:ext>
             </a:extLst>
           </p:cNvPr>
@@ -10679,7 +10679,7 @@
               <p:cNvPr id="26" name="CasellaDiTesto 25">
                 <a:extLst>
                   <a:ext uri="{FF2B5EF4-FFF2-40B4-BE49-F238E27FC236}">
-                    <a16:creationId xmlns:a16="http://schemas.microsoft.com/office/drawing/2014/main" xmlns="" id="{10FA4CB3-80F7-C503-0472-6028A71F233F}"/>
+                    <a16:creationId xmlns="" xmlns:a16="http://schemas.microsoft.com/office/drawing/2014/main" id="{10FA4CB3-80F7-C503-0472-6028A71F233F}"/>
                   </a:ext>
                 </a:extLst>
               </p:cNvPr>
@@ -10986,7 +10986,7 @@
           <p:cNvPr id="29" name="CasellaDiTesto 28">
             <a:extLst>
               <a:ext uri="{FF2B5EF4-FFF2-40B4-BE49-F238E27FC236}">
-                <a16:creationId xmlns:a16="http://schemas.microsoft.com/office/drawing/2014/main" xmlns="" id="{D8306A3A-A8A6-6D5A-F6B0-F90FE70295D1}"/>
+                <a16:creationId xmlns="" xmlns:a16="http://schemas.microsoft.com/office/drawing/2014/main" id="{D8306A3A-A8A6-6D5A-F6B0-F90FE70295D1}"/>
               </a:ext>
             </a:extLst>
           </p:cNvPr>
@@ -11022,7 +11022,7 @@
           <p:cNvPr id="31" name="Connettore 2 30">
             <a:extLst>
               <a:ext uri="{FF2B5EF4-FFF2-40B4-BE49-F238E27FC236}">
-                <a16:creationId xmlns:a16="http://schemas.microsoft.com/office/drawing/2014/main" xmlns="" id="{1118F58F-2ECB-A8B1-53A7-A13C9B1BF899}"/>
+                <a16:creationId xmlns="" xmlns:a16="http://schemas.microsoft.com/office/drawing/2014/main" id="{1118F58F-2ECB-A8B1-53A7-A13C9B1BF899}"/>
               </a:ext>
             </a:extLst>
           </p:cNvPr>
@@ -11067,7 +11067,7 @@
           <p:cNvPr id="33" name="CasellaDiTesto 32">
             <a:extLst>
               <a:ext uri="{FF2B5EF4-FFF2-40B4-BE49-F238E27FC236}">
-                <a16:creationId xmlns:a16="http://schemas.microsoft.com/office/drawing/2014/main" xmlns="" id="{0CA5A70B-FBB6-1442-B82F-BCAEF14943CF}"/>
+                <a16:creationId xmlns="" xmlns:a16="http://schemas.microsoft.com/office/drawing/2014/main" id="{0CA5A70B-FBB6-1442-B82F-BCAEF14943CF}"/>
               </a:ext>
             </a:extLst>
           </p:cNvPr>
@@ -11103,7 +11103,7 @@
           <p:cNvPr id="39" name="Connettore 2 38">
             <a:extLst>
               <a:ext uri="{FF2B5EF4-FFF2-40B4-BE49-F238E27FC236}">
-                <a16:creationId xmlns:a16="http://schemas.microsoft.com/office/drawing/2014/main" xmlns="" id="{DBA6A395-F65E-A076-8E0E-3EB923726BC6}"/>
+                <a16:creationId xmlns="" xmlns:a16="http://schemas.microsoft.com/office/drawing/2014/main" id="{DBA6A395-F65E-A076-8E0E-3EB923726BC6}"/>
               </a:ext>
             </a:extLst>
           </p:cNvPr>
@@ -11148,7 +11148,7 @@
           <p:cNvPr id="50" name="CasellaDiTesto 49">
             <a:extLst>
               <a:ext uri="{FF2B5EF4-FFF2-40B4-BE49-F238E27FC236}">
-                <a16:creationId xmlns:a16="http://schemas.microsoft.com/office/drawing/2014/main" xmlns="" id="{1B62B1CA-1600-6AFA-836D-D51C4D2C2990}"/>
+                <a16:creationId xmlns="" xmlns:a16="http://schemas.microsoft.com/office/drawing/2014/main" id="{1B62B1CA-1600-6AFA-836D-D51C4D2C2990}"/>
               </a:ext>
             </a:extLst>
           </p:cNvPr>
@@ -11186,7 +11186,7 @@
           <p:cNvPr id="51" name="Connettore 2 50">
             <a:extLst>
               <a:ext uri="{FF2B5EF4-FFF2-40B4-BE49-F238E27FC236}">
-                <a16:creationId xmlns:a16="http://schemas.microsoft.com/office/drawing/2014/main" xmlns="" id="{D58FBD34-601B-BFAC-0743-979D15D9640D}"/>
+                <a16:creationId xmlns="" xmlns:a16="http://schemas.microsoft.com/office/drawing/2014/main" id="{D58FBD34-601B-BFAC-0743-979D15D9640D}"/>
               </a:ext>
             </a:extLst>
           </p:cNvPr>
@@ -11263,7 +11263,7 @@
           <p:cNvPr id="6" name="CasellaDiTesto 5">
             <a:extLst>
               <a:ext uri="{FF2B5EF4-FFF2-40B4-BE49-F238E27FC236}">
-                <a16:creationId xmlns:a16="http://schemas.microsoft.com/office/drawing/2014/main" xmlns="" id="{926E6FB1-2736-3FC3-D13C-D3A4F1A4559E}"/>
+                <a16:creationId xmlns="" xmlns:a16="http://schemas.microsoft.com/office/drawing/2014/main" id="{926E6FB1-2736-3FC3-D13C-D3A4F1A4559E}"/>
               </a:ext>
             </a:extLst>
           </p:cNvPr>
@@ -11403,7 +11403,7 @@
               <p:cNvPr id="8" name="CasellaDiTesto 7">
                 <a:extLst>
                   <a:ext uri="{FF2B5EF4-FFF2-40B4-BE49-F238E27FC236}">
-                    <a16:creationId xmlns:a16="http://schemas.microsoft.com/office/drawing/2014/main" xmlns="" id="{9B05F113-BC03-4C9A-FB01-5654BBD959AB}"/>
+                    <a16:creationId xmlns="" xmlns:a16="http://schemas.microsoft.com/office/drawing/2014/main" id="{9B05F113-BC03-4C9A-FB01-5654BBD959AB}"/>
                   </a:ext>
                 </a:extLst>
               </p:cNvPr>
@@ -11785,7 +11785,7 @@
           <p:cNvPr id="9" name="CasellaDiTesto 8">
             <a:extLst>
               <a:ext uri="{FF2B5EF4-FFF2-40B4-BE49-F238E27FC236}">
-                <a16:creationId xmlns:a16="http://schemas.microsoft.com/office/drawing/2014/main" xmlns="" id="{1F3F5F1F-5789-C5E8-83BB-93DD71E28090}"/>
+                <a16:creationId xmlns="" xmlns:a16="http://schemas.microsoft.com/office/drawing/2014/main" id="{1F3F5F1F-5789-C5E8-83BB-93DD71E28090}"/>
               </a:ext>
             </a:extLst>
           </p:cNvPr>
@@ -11826,7 +11826,7 @@
           <p:cNvPr id="10" name="CasellaDiTesto 9">
             <a:extLst>
               <a:ext uri="{FF2B5EF4-FFF2-40B4-BE49-F238E27FC236}">
-                <a16:creationId xmlns:a16="http://schemas.microsoft.com/office/drawing/2014/main" xmlns="" id="{077186E1-E6B6-8A74-1DA2-1C88ED4E7A42}"/>
+                <a16:creationId xmlns="" xmlns:a16="http://schemas.microsoft.com/office/drawing/2014/main" id="{077186E1-E6B6-8A74-1DA2-1C88ED4E7A42}"/>
               </a:ext>
             </a:extLst>
           </p:cNvPr>
@@ -11864,7 +11864,7 @@
           <p:cNvPr id="11" name="Connettore 2 10">
             <a:extLst>
               <a:ext uri="{FF2B5EF4-FFF2-40B4-BE49-F238E27FC236}">
-                <a16:creationId xmlns:a16="http://schemas.microsoft.com/office/drawing/2014/main" xmlns="" id="{5792884F-67AB-F216-2AB6-45702467EBB7}"/>
+                <a16:creationId xmlns="" xmlns:a16="http://schemas.microsoft.com/office/drawing/2014/main" id="{5792884F-67AB-F216-2AB6-45702467EBB7}"/>
               </a:ext>
             </a:extLst>
           </p:cNvPr>
@@ -11908,7 +11908,7 @@
           <p:cNvPr id="13" name="Immagine 12" descr="Immagine che contiene testo, schermata, Diagramma, diagramma&#10;&#10;Il contenuto generato dall'IA potrebbe non essere corretto.">
             <a:extLst>
               <a:ext uri="{FF2B5EF4-FFF2-40B4-BE49-F238E27FC236}">
-                <a16:creationId xmlns:a16="http://schemas.microsoft.com/office/drawing/2014/main" xmlns="" id="{D07778A6-4858-F3FC-F979-B795C5F4BE0C}"/>
+                <a16:creationId xmlns="" xmlns:a16="http://schemas.microsoft.com/office/drawing/2014/main" id="{D07778A6-4858-F3FC-F979-B795C5F4BE0C}"/>
               </a:ext>
             </a:extLst>
           </p:cNvPr>
@@ -11944,7 +11944,7 @@
           <p:cNvPr id="15" name="Immagine 14" descr="Immagine che contiene schermata, Diagramma, linea, Carattere&#10;&#10;Il contenuto generato dall'IA potrebbe non essere corretto.">
             <a:extLst>
               <a:ext uri="{FF2B5EF4-FFF2-40B4-BE49-F238E27FC236}">
-                <a16:creationId xmlns:a16="http://schemas.microsoft.com/office/drawing/2014/main" xmlns="" id="{59936905-4491-A247-4C59-DBEE90714821}"/>
+                <a16:creationId xmlns="" xmlns:a16="http://schemas.microsoft.com/office/drawing/2014/main" id="{59936905-4491-A247-4C59-DBEE90714821}"/>
               </a:ext>
             </a:extLst>
           </p:cNvPr>
@@ -11990,7 +11990,7 @@
   </p:transition>
   <p:extLst mod="1">
     <p:ext uri="{6950BFC3-D8DA-4A85-94F7-54DA5524770B}">
-      <p188:commentRel xmlns:p188="http://schemas.microsoft.com/office/powerpoint/2018/8/main" xmlns="" r:id="rId2"/>
+      <p188:commentRel xmlns="" xmlns:p188="http://schemas.microsoft.com/office/powerpoint/2018/8/main" r:id="rId2"/>
     </p:ext>
   </p:extLst>
 </p:sld>
@@ -12018,7 +12018,7 @@
           <p:cNvPr id="9" name="CasellaDiTesto 8">
             <a:extLst>
               <a:ext uri="{FF2B5EF4-FFF2-40B4-BE49-F238E27FC236}">
-                <a16:creationId xmlns:a16="http://schemas.microsoft.com/office/drawing/2014/main" xmlns="" id="{4E944B30-1E64-4B9D-B38B-0C47B2A5A81F}"/>
+                <a16:creationId xmlns="" xmlns:a16="http://schemas.microsoft.com/office/drawing/2014/main" id="{4E944B30-1E64-4B9D-B38B-0C47B2A5A81F}"/>
               </a:ext>
             </a:extLst>
           </p:cNvPr>
@@ -12059,7 +12059,7 @@
           <p:cNvPr id="10" name="CasellaDiTesto 9">
             <a:extLst>
               <a:ext uri="{FF2B5EF4-FFF2-40B4-BE49-F238E27FC236}">
-                <a16:creationId xmlns:a16="http://schemas.microsoft.com/office/drawing/2014/main" xmlns="" id="{749DDA58-F4C8-52B8-0E3B-0EAA3B56A8DD}"/>
+                <a16:creationId xmlns="" xmlns:a16="http://schemas.microsoft.com/office/drawing/2014/main" id="{749DDA58-F4C8-52B8-0E3B-0EAA3B56A8DD}"/>
               </a:ext>
             </a:extLst>
           </p:cNvPr>
@@ -12108,7 +12108,7 @@
           <p:cNvPr id="11" name="CasellaDiTesto 10">
             <a:extLst>
               <a:ext uri="{FF2B5EF4-FFF2-40B4-BE49-F238E27FC236}">
-                <a16:creationId xmlns:a16="http://schemas.microsoft.com/office/drawing/2014/main" xmlns="" id="{7A2D5E21-8230-989D-23E9-65BB72125539}"/>
+                <a16:creationId xmlns="" xmlns:a16="http://schemas.microsoft.com/office/drawing/2014/main" id="{7A2D5E21-8230-989D-23E9-65BB72125539}"/>
               </a:ext>
             </a:extLst>
           </p:cNvPr>
@@ -12157,7 +12157,7 @@
           <p:cNvPr id="12" name="CasellaDiTesto 11">
             <a:extLst>
               <a:ext uri="{FF2B5EF4-FFF2-40B4-BE49-F238E27FC236}">
-                <a16:creationId xmlns:a16="http://schemas.microsoft.com/office/drawing/2014/main" xmlns="" id="{44EF67DB-C0DA-EFD0-56F5-2FF6C0D7C852}"/>
+                <a16:creationId xmlns="" xmlns:a16="http://schemas.microsoft.com/office/drawing/2014/main" id="{44EF67DB-C0DA-EFD0-56F5-2FF6C0D7C852}"/>
               </a:ext>
             </a:extLst>
           </p:cNvPr>
@@ -12196,7 +12196,7 @@
           <p:cNvPr id="13" name="CasellaDiTesto 12">
             <a:extLst>
               <a:ext uri="{FF2B5EF4-FFF2-40B4-BE49-F238E27FC236}">
-                <a16:creationId xmlns:a16="http://schemas.microsoft.com/office/drawing/2014/main" xmlns="" id="{2CFBDF99-CF43-08E0-322C-DCC1A669DD89}"/>
+                <a16:creationId xmlns="" xmlns:a16="http://schemas.microsoft.com/office/drawing/2014/main" id="{2CFBDF99-CF43-08E0-322C-DCC1A669DD89}"/>
               </a:ext>
             </a:extLst>
           </p:cNvPr>
@@ -12235,7 +12235,7 @@
           <p:cNvPr id="14" name="Connettore diritto 13">
             <a:extLst>
               <a:ext uri="{FF2B5EF4-FFF2-40B4-BE49-F238E27FC236}">
-                <a16:creationId xmlns:a16="http://schemas.microsoft.com/office/drawing/2014/main" xmlns="" id="{10D603BC-6289-7465-3078-19FB10744AB5}"/>
+                <a16:creationId xmlns="" xmlns:a16="http://schemas.microsoft.com/office/drawing/2014/main" id="{10D603BC-6289-7465-3078-19FB10744AB5}"/>
               </a:ext>
             </a:extLst>
           </p:cNvPr>
@@ -12278,7 +12278,7 @@
           <p:cNvPr id="15" name="Connettore diritto 14">
             <a:extLst>
               <a:ext uri="{FF2B5EF4-FFF2-40B4-BE49-F238E27FC236}">
-                <a16:creationId xmlns:a16="http://schemas.microsoft.com/office/drawing/2014/main" xmlns="" id="{37214E4B-CB3E-2F6F-9802-67D07D43737B}"/>
+                <a16:creationId xmlns="" xmlns:a16="http://schemas.microsoft.com/office/drawing/2014/main" id="{37214E4B-CB3E-2F6F-9802-67D07D43737B}"/>
               </a:ext>
             </a:extLst>
           </p:cNvPr>
@@ -12323,7 +12323,7 @@
               <p:cNvPr id="18" name="CasellaDiTesto 17">
                 <a:extLst>
                   <a:ext uri="{FF2B5EF4-FFF2-40B4-BE49-F238E27FC236}">
-                    <a16:creationId xmlns:a16="http://schemas.microsoft.com/office/drawing/2014/main" xmlns="" id="{F791A810-11FB-DBD4-6D3C-E20A8E6F9E9B}"/>
+                    <a16:creationId xmlns="" xmlns:a16="http://schemas.microsoft.com/office/drawing/2014/main" id="{F791A810-11FB-DBD4-6D3C-E20A8E6F9E9B}"/>
                   </a:ext>
                 </a:extLst>
               </p:cNvPr>
@@ -12442,7 +12442,7 @@
               <p:cNvPr id="19" name="CasellaDiTesto 18">
                 <a:extLst>
                   <a:ext uri="{FF2B5EF4-FFF2-40B4-BE49-F238E27FC236}">
-                    <a16:creationId xmlns:a16="http://schemas.microsoft.com/office/drawing/2014/main" xmlns="" id="{9614D353-C2E2-BDB5-ABA3-55F4675A17B8}"/>
+                    <a16:creationId xmlns="" xmlns:a16="http://schemas.microsoft.com/office/drawing/2014/main" id="{9614D353-C2E2-BDB5-ABA3-55F4675A17B8}"/>
                   </a:ext>
                 </a:extLst>
               </p:cNvPr>
@@ -12562,7 +12562,7 @@
           <p:cNvPr id="22" name="CasellaDiTesto 21">
             <a:extLst>
               <a:ext uri="{FF2B5EF4-FFF2-40B4-BE49-F238E27FC236}">
-                <a16:creationId xmlns:a16="http://schemas.microsoft.com/office/drawing/2014/main" xmlns="" id="{36AC219C-E603-2007-9C76-BEBE285DE0CB}"/>
+                <a16:creationId xmlns="" xmlns:a16="http://schemas.microsoft.com/office/drawing/2014/main" id="{36AC219C-E603-2007-9C76-BEBE285DE0CB}"/>
               </a:ext>
             </a:extLst>
           </p:cNvPr>
@@ -12601,7 +12601,7 @@
           <p:cNvPr id="23" name="CasellaDiTesto 22">
             <a:extLst>
               <a:ext uri="{FF2B5EF4-FFF2-40B4-BE49-F238E27FC236}">
-                <a16:creationId xmlns:a16="http://schemas.microsoft.com/office/drawing/2014/main" xmlns="" id="{77093B05-4195-E939-8512-86AAEC2D6EE5}"/>
+                <a16:creationId xmlns="" xmlns:a16="http://schemas.microsoft.com/office/drawing/2014/main" id="{77093B05-4195-E939-8512-86AAEC2D6EE5}"/>
               </a:ext>
             </a:extLst>
           </p:cNvPr>
@@ -12640,7 +12640,7 @@
           <p:cNvPr id="24" name="Connettore 2 23">
             <a:extLst>
               <a:ext uri="{FF2B5EF4-FFF2-40B4-BE49-F238E27FC236}">
-                <a16:creationId xmlns:a16="http://schemas.microsoft.com/office/drawing/2014/main" xmlns="" id="{7256209A-4B60-F46E-7359-4280FA7EB910}"/>
+                <a16:creationId xmlns="" xmlns:a16="http://schemas.microsoft.com/office/drawing/2014/main" id="{7256209A-4B60-F46E-7359-4280FA7EB910}"/>
               </a:ext>
             </a:extLst>
           </p:cNvPr>
@@ -12686,7 +12686,7 @@
           <p:cNvPr id="27" name="Connettore 2 26">
             <a:extLst>
               <a:ext uri="{FF2B5EF4-FFF2-40B4-BE49-F238E27FC236}">
-                <a16:creationId xmlns:a16="http://schemas.microsoft.com/office/drawing/2014/main" xmlns="" id="{A224F907-21AA-592B-0AA8-94911F697A09}"/>
+                <a16:creationId xmlns="" xmlns:a16="http://schemas.microsoft.com/office/drawing/2014/main" id="{A224F907-21AA-592B-0AA8-94911F697A09}"/>
               </a:ext>
             </a:extLst>
           </p:cNvPr>
@@ -12734,7 +12734,7 @@
               <p:cNvPr id="36" name="CasellaDiTesto 35">
                 <a:extLst>
                   <a:ext uri="{FF2B5EF4-FFF2-40B4-BE49-F238E27FC236}">
-                    <a16:creationId xmlns:a16="http://schemas.microsoft.com/office/drawing/2014/main" xmlns="" id="{8335F639-E7CC-6BB1-4379-55E2376536D8}"/>
+                    <a16:creationId xmlns="" xmlns:a16="http://schemas.microsoft.com/office/drawing/2014/main" id="{8335F639-E7CC-6BB1-4379-55E2376536D8}"/>
                   </a:ext>
                 </a:extLst>
               </p:cNvPr>
@@ -12836,7 +12836,7 @@
               <p:cNvPr id="37" name="CasellaDiTesto 36">
                 <a:extLst>
                   <a:ext uri="{FF2B5EF4-FFF2-40B4-BE49-F238E27FC236}">
-                    <a16:creationId xmlns:a16="http://schemas.microsoft.com/office/drawing/2014/main" xmlns="" id="{C573B21C-9425-BC55-4FFF-AF4F13B2A685}"/>
+                    <a16:creationId xmlns="" xmlns:a16="http://schemas.microsoft.com/office/drawing/2014/main" id="{C573B21C-9425-BC55-4FFF-AF4F13B2A685}"/>
                   </a:ext>
                 </a:extLst>
               </p:cNvPr>
@@ -12949,7 +12949,7 @@
           <p:cNvPr id="41" name="Immagine 40" descr="Immagine che contiene diagramma, Diagramma, linea, testo&#10;&#10;Il contenuto generato dall'IA potrebbe non essere corretto.">
             <a:extLst>
               <a:ext uri="{FF2B5EF4-FFF2-40B4-BE49-F238E27FC236}">
-                <a16:creationId xmlns:a16="http://schemas.microsoft.com/office/drawing/2014/main" xmlns="" id="{08A02B52-5365-9DB8-980B-E3220494EA68}"/>
+                <a16:creationId xmlns="" xmlns:a16="http://schemas.microsoft.com/office/drawing/2014/main" id="{08A02B52-5365-9DB8-980B-E3220494EA68}"/>
               </a:ext>
             </a:extLst>
           </p:cNvPr>
@@ -13271,7 +13271,7 @@
   <a:extraClrSchemeLst/>
   <a:extLst>
     <a:ext uri="{05A4C25C-085E-4340-85A3-A5531E510DB2}">
-      <thm15:themeFamily xmlns:thm15="http://schemas.microsoft.com/office/thememl/2012/main" xmlns="" name="Office Theme" id="{2E142A2C-CD16-42D6-873A-C26D2A0506FA}" vid="{1BDDFF52-6CD6-40A5-AB3C-68EB2F1E4D0A}"/>
+      <thm15:themeFamily xmlns="" xmlns:thm15="http://schemas.microsoft.com/office/thememl/2012/main" name="Office Theme" id="{2E142A2C-CD16-42D6-873A-C26D2A0506FA}" vid="{1BDDFF52-6CD6-40A5-AB3C-68EB2F1E4D0A}"/>
     </a:ext>
   </a:extLst>
 </a:theme>

</xml_diff>